<commit_message>
fix: blocs optionnels toujours visibles quelle que soit la version
Les optionnels viennent désormais de la liste complète des slides
(pas des indices filtrés par version) — ils représentent du contenu
bonus "si le temps le permet", pertinent même pour la fiche 1h.
Regénère les 60 fiches (20 ateliers × 3 versions).
</commit_message>
<xml_diff>
--- a/assets/fiches/A6-fiche-1h.pptx
+++ b/assets/fiches/A6-fiche-1h.pptx
@@ -5765,7 +5765,7 @@
           <p:nvPr/>
         </p:nvGraphicFramePr>
         <p:xfrm>
-          <a:off x="-10000000" y="7868790"/>
+          <a:off x="533400" y="7868790"/>
           <a:ext cx="6457950" cy="1663063"/>
         </p:xfrm>
         <a:graphic>
@@ -6051,27 +6051,7 @@
                           <a:latin typeface="Arial"/>
                           <a:cs typeface="Arial"/>
                         </a:rPr>
-                        <a:t>15</a:t>
-                      </a:r>
-                      <a:r>
-                        <a:rPr sz="850" b="1" spc="-10" dirty="0">
-                          <a:solidFill>
-                            <a:srgbClr val="E67D21"/>
-                          </a:solidFill>
-                          <a:latin typeface="Arial"/>
-                          <a:cs typeface="Arial"/>
-                        </a:rPr>
-                        <a:t> </a:t>
-                      </a:r>
-                      <a:r>
-                        <a:rPr sz="850" b="1" spc="-25" dirty="0">
-                          <a:solidFill>
-                            <a:srgbClr val="E67D21"/>
-                          </a:solidFill>
-                          <a:latin typeface="Arial"/>
-                          <a:cs typeface="Arial"/>
-                        </a:rPr>
-                        <a:t>min</a:t>
+                        <a:t>8 min</a:t>
                       </a:r>
                       <a:endParaRPr sz="850">
                         <a:latin typeface="Arial"/>
@@ -6092,7 +6072,7 @@
                           <a:latin typeface="Arial"/>
                           <a:cs typeface="Arial"/>
                         </a:rPr>
-                        <a:t>Teleconsultation</a:t>
+                        <a:t>Numérique responsable</a:t>
                       </a:r>
                       <a:endParaRPr sz="1050">
                         <a:latin typeface="Arial"/>
@@ -6121,140 +6101,17 @@
                         </a:rPr>
                         <a:t>OPT.</a:t>
                       </a:r>
-                      <a:r>
-                        <a:rPr sz="1200" b="1" baseline="13888" dirty="0">
-                          <a:solidFill>
-                            <a:srgbClr val="FFFFFF"/>
-                          </a:solidFill>
-                          <a:latin typeface="Arial"/>
-                          <a:cs typeface="Arial"/>
-                        </a:rPr>
-                        <a:t>	</a:t>
-                      </a:r>
-                      <a:r>
-                        <a:rPr sz="900" dirty="0">
-                          <a:solidFill>
-                            <a:srgbClr val="2B2B2B"/>
-                          </a:solidFill>
-                          <a:latin typeface="Arial"/>
-                          <a:cs typeface="Arial"/>
-                        </a:rPr>
-                        <a:t>.</a:t>
-                      </a:r>
-                      <a:r>
-                        <a:rPr sz="900" spc="-5" dirty="0">
-                          <a:solidFill>
-                            <a:srgbClr val="2B2B2B"/>
-                          </a:solidFill>
-                          <a:latin typeface="Arial"/>
-                          <a:cs typeface="Arial"/>
-                        </a:rPr>
-                        <a:t> </a:t>
-                      </a:r>
-                      <a:r>
-                        <a:rPr sz="900" dirty="0">
-                          <a:solidFill>
-                            <a:srgbClr val="2B2B2B"/>
-                          </a:solidFill>
-                          <a:latin typeface="Arial"/>
-                          <a:cs typeface="Arial"/>
-                        </a:rPr>
-                        <a:t>Expliquer</a:t>
-                      </a:r>
-                      <a:r>
-                        <a:rPr sz="900" spc="-5" dirty="0">
-                          <a:solidFill>
-                            <a:srgbClr val="2B2B2B"/>
-                          </a:solidFill>
-                          <a:latin typeface="Arial"/>
-                          <a:cs typeface="Arial"/>
-                        </a:rPr>
-                        <a:t> </a:t>
-                      </a:r>
-                      <a:r>
-                        <a:rPr sz="900" dirty="0">
-                          <a:solidFill>
-                            <a:srgbClr val="2B2B2B"/>
-                          </a:solidFill>
-                          <a:latin typeface="Arial"/>
-                          <a:cs typeface="Arial"/>
-                        </a:rPr>
-                        <a:t>ce qu'est</a:t>
-                      </a:r>
-                      <a:r>
-                        <a:rPr sz="900" spc="-5" dirty="0">
-                          <a:solidFill>
-                            <a:srgbClr val="2B2B2B"/>
-                          </a:solidFill>
-                          <a:latin typeface="Arial"/>
-                          <a:cs typeface="Arial"/>
-                        </a:rPr>
-                        <a:t> </a:t>
-                      </a:r>
-                      <a:r>
-                        <a:rPr sz="900" dirty="0">
-                          <a:solidFill>
-                            <a:srgbClr val="2B2B2B"/>
-                          </a:solidFill>
-                          <a:latin typeface="Arial"/>
-                          <a:cs typeface="Arial"/>
-                        </a:rPr>
-                        <a:t>la teleconsultation</a:t>
-                      </a:r>
-                      <a:r>
-                        <a:rPr sz="900" spc="-5" dirty="0">
-                          <a:solidFill>
-                            <a:srgbClr val="2B2B2B"/>
-                          </a:solidFill>
-                          <a:latin typeface="Arial"/>
-                          <a:cs typeface="Arial"/>
-                        </a:rPr>
-                        <a:t> </a:t>
-                      </a:r>
-                      <a:r>
-                        <a:rPr sz="900" dirty="0">
-                          <a:solidFill>
-                            <a:srgbClr val="2B2B2B"/>
-                          </a:solidFill>
-                          <a:latin typeface="Arial"/>
-                          <a:cs typeface="Arial"/>
-                        </a:rPr>
-                        <a:t>et</a:t>
-                      </a:r>
-                      <a:r>
-                        <a:rPr sz="900" spc="-5" dirty="0">
-                          <a:solidFill>
-                            <a:srgbClr val="2B2B2B"/>
-                          </a:solidFill>
-                          <a:latin typeface="Arial"/>
-                          <a:cs typeface="Arial"/>
-                        </a:rPr>
-                        <a:t> </a:t>
-                      </a:r>
-                      <a:r>
-                        <a:rPr sz="900" dirty="0">
-                          <a:solidFill>
-                            <a:srgbClr val="2B2B2B"/>
-                          </a:solidFill>
-                          <a:latin typeface="Arial"/>
-                          <a:cs typeface="Arial"/>
-                        </a:rPr>
-                        <a:t>son </a:t>
-                      </a:r>
-                      <a:r>
-                        <a:rPr sz="900" spc="-10" dirty="0">
-                          <a:solidFill>
-                            <a:srgbClr val="2B2B2B"/>
-                          </a:solidFill>
-                          <a:latin typeface="Arial"/>
-                          <a:cs typeface="Arial"/>
-                        </a:rPr>
-                        <a:t>remboursement</a:t>
-                      </a:r>
                       <a:endParaRPr sz="900">
                         <a:latin typeface="Arial"/>
                         <a:cs typeface="Arial"/>
                       </a:endParaRPr>
+                      <a:r>
+                        <a:rPr sz="900" spc="-30" baseline="13888" dirty="0">
+                          <a:latin typeface="Arial"/>
+                          <a:cs typeface="Arial"/>
+                        </a:rPr>
+                        <a:t>	. Sécurité et sobriété numérique : deux alliés</a:t>
+                      </a:r>
                     </a:p>
                     <a:p>
                       <a:pPr marL="755650">
@@ -6270,17 +6127,7 @@
                           <a:latin typeface="Arial"/>
                           <a:cs typeface="Arial"/>
                         </a:rPr>
-                        <a:t>. Montrer comment reperer un medecin proposant la </a:t>
-                      </a:r>
-                      <a:r>
-                        <a:rPr sz="900" spc="-10" dirty="0">
-                          <a:solidFill>
-                            <a:srgbClr val="2B2B2B"/>
-                          </a:solidFill>
-                          <a:latin typeface="Arial"/>
-                          <a:cs typeface="Arial"/>
-                        </a:rPr>
-                        <a:t>video</a:t>
+                        <a:t>. La sécurité numérique et la sobriété vont de pair. Moins d'applications ins…</a:t>
                       </a:r>
                       <a:endParaRPr sz="900">
                         <a:latin typeface="Arial"/>
@@ -6301,17 +6148,7 @@
                           <a:latin typeface="Arial"/>
                           <a:cs typeface="Arial"/>
                         </a:rPr>
-                        <a:t>. Simuler la reception du lien et le demarrage de la </a:t>
-                      </a:r>
-                      <a:r>
-                        <a:rPr sz="900" spc="-10" dirty="0">
-                          <a:solidFill>
-                            <a:srgbClr val="2B2B2B"/>
-                          </a:solidFill>
-                          <a:latin typeface="Arial"/>
-                          <a:cs typeface="Arial"/>
-                        </a:rPr>
-                        <a:t>session</a:t>
+                        <a:t>. Faites le ménage dans vos applications</a:t>
                       </a:r>
                       <a:endParaRPr sz="900">
                         <a:latin typeface="Arial"/>
@@ -6366,36 +6203,6 @@
                           <a:spcPts val="250"/>
                         </a:spcBef>
                       </a:pPr>
-                      <a:r>
-                        <a:rPr sz="850" b="1" dirty="0">
-                          <a:solidFill>
-                            <a:srgbClr val="E67D21"/>
-                          </a:solidFill>
-                          <a:latin typeface="Arial"/>
-                          <a:cs typeface="Arial"/>
-                        </a:rPr>
-                        <a:t>10</a:t>
-                      </a:r>
-                      <a:r>
-                        <a:rPr sz="850" b="1" spc="-10" dirty="0">
-                          <a:solidFill>
-                            <a:srgbClr val="E67D21"/>
-                          </a:solidFill>
-                          <a:latin typeface="Arial"/>
-                          <a:cs typeface="Arial"/>
-                        </a:rPr>
-                        <a:t> </a:t>
-                      </a:r>
-                      <a:r>
-                        <a:rPr sz="850" b="1" spc="-25" dirty="0">
-                          <a:solidFill>
-                            <a:srgbClr val="E67D21"/>
-                          </a:solidFill>
-                          <a:latin typeface="Arial"/>
-                          <a:cs typeface="Arial"/>
-                        </a:rPr>
-                        <a:t>min</a:t>
-                      </a:r>
                       <a:endParaRPr sz="850">
                         <a:latin typeface="Arial"/>
                         <a:cs typeface="Arial"/>
@@ -6407,76 +6214,6 @@
                           <a:spcPts val="1200"/>
                         </a:lnSpc>
                       </a:pPr>
-                      <a:r>
-                        <a:rPr sz="1050" b="1" dirty="0">
-                          <a:solidFill>
-                            <a:srgbClr val="2B2B2B"/>
-                          </a:solidFill>
-                          <a:latin typeface="Arial"/>
-                          <a:cs typeface="Arial"/>
-                        </a:rPr>
-                        <a:t>Acceder</a:t>
-                      </a:r>
-                      <a:r>
-                        <a:rPr sz="1050" b="1" spc="-25" dirty="0">
-                          <a:solidFill>
-                            <a:srgbClr val="2B2B2B"/>
-                          </a:solidFill>
-                          <a:latin typeface="Arial"/>
-                          <a:cs typeface="Arial"/>
-                        </a:rPr>
-                        <a:t> </a:t>
-                      </a:r>
-                      <a:r>
-                        <a:rPr sz="1050" b="1" dirty="0">
-                          <a:solidFill>
-                            <a:srgbClr val="2B2B2B"/>
-                          </a:solidFill>
-                          <a:latin typeface="Arial"/>
-                          <a:cs typeface="Arial"/>
-                        </a:rPr>
-                        <a:t>a</a:t>
-                      </a:r>
-                      <a:r>
-                        <a:rPr sz="1050" b="1" spc="-25" dirty="0">
-                          <a:solidFill>
-                            <a:srgbClr val="2B2B2B"/>
-                          </a:solidFill>
-                          <a:latin typeface="Arial"/>
-                          <a:cs typeface="Arial"/>
-                        </a:rPr>
-                        <a:t> </a:t>
-                      </a:r>
-                      <a:r>
-                        <a:rPr sz="1050" b="1" dirty="0">
-                          <a:solidFill>
-                            <a:srgbClr val="2B2B2B"/>
-                          </a:solidFill>
-                          <a:latin typeface="Arial"/>
-                          <a:cs typeface="Arial"/>
-                        </a:rPr>
-                        <a:t>mes</a:t>
-                      </a:r>
-                      <a:r>
-                        <a:rPr sz="1050" b="1" spc="-20" dirty="0">
-                          <a:solidFill>
-                            <a:srgbClr val="2B2B2B"/>
-                          </a:solidFill>
-                          <a:latin typeface="Arial"/>
-                          <a:cs typeface="Arial"/>
-                        </a:rPr>
-                        <a:t> </a:t>
-                      </a:r>
-                      <a:r>
-                        <a:rPr sz="1050" b="1" spc="-10" dirty="0">
-                          <a:solidFill>
-                            <a:srgbClr val="2B2B2B"/>
-                          </a:solidFill>
-                          <a:latin typeface="Arial"/>
-                          <a:cs typeface="Arial"/>
-                        </a:rPr>
-                        <a:t>documents</a:t>
-                      </a:r>
                       <a:endParaRPr sz="1050">
                         <a:latin typeface="Arial"/>
                         <a:cs typeface="Arial"/>
@@ -6494,46 +6231,6 @@
                           <a:tab pos="524510" algn="l"/>
                         </a:tabLst>
                       </a:pPr>
-                      <a:r>
-                        <a:rPr sz="1200" b="1" spc="-30" baseline="13888" dirty="0">
-                          <a:solidFill>
-                            <a:srgbClr val="FFFFFF"/>
-                          </a:solidFill>
-                          <a:latin typeface="Arial"/>
-                          <a:cs typeface="Arial"/>
-                        </a:rPr>
-                        <a:t>OPT.</a:t>
-                      </a:r>
-                      <a:r>
-                        <a:rPr sz="1200" b="1" baseline="13888" dirty="0">
-                          <a:solidFill>
-                            <a:srgbClr val="FFFFFF"/>
-                          </a:solidFill>
-                          <a:latin typeface="Arial"/>
-                          <a:cs typeface="Arial"/>
-                        </a:rPr>
-                        <a:t>	</a:t>
-                      </a:r>
-                      <a:r>
-                        <a:rPr sz="900" dirty="0">
-                          <a:solidFill>
-                            <a:srgbClr val="2B2B2B"/>
-                          </a:solidFill>
-                          <a:latin typeface="Arial"/>
-                          <a:cs typeface="Arial"/>
-                        </a:rPr>
-                        <a:t>. Naviguer vers Mon espace sante &gt; Mes </a:t>
-                      </a:r>
-                      <a:r>
-                        <a:rPr sz="900" spc="-10" dirty="0">
-                          <a:solidFill>
-                            <a:srgbClr val="2B2B2B"/>
-                          </a:solidFill>
-                          <a:latin typeface="Arial"/>
-                          <a:cs typeface="Arial"/>
-                        </a:rPr>
-                        <a:t>documents</a:t>
-                      </a:r>
                       <a:endParaRPr sz="900">
                         <a:latin typeface="Arial"/>
                         <a:cs typeface="Arial"/>
@@ -6545,26 +6242,6 @@
                           <a:spcPts val="1050"/>
                         </a:lnSpc>
                       </a:pPr>
-                      <a:r>
-                        <a:rPr sz="900" dirty="0">
-                          <a:solidFill>
-                            <a:srgbClr val="2B2B2B"/>
-                          </a:solidFill>
-                          <a:latin typeface="Arial"/>
-                          <a:cs typeface="Arial"/>
-                        </a:rPr>
-                        <a:t>. Retrouver une ordonnance ou un resultat </a:t>
-                      </a:r>
-                      <a:r>
-                        <a:rPr sz="900" spc="-10" dirty="0">
-                          <a:solidFill>
-                            <a:srgbClr val="2B2B2B"/>
-                          </a:solidFill>
-                          <a:latin typeface="Arial"/>
-                          <a:cs typeface="Arial"/>
-                        </a:rPr>
-                        <a:t>d'analyse</a:t>
-                      </a:r>
                       <a:endParaRPr sz="900">
                         <a:latin typeface="Arial"/>
                         <a:cs typeface="Arial"/>
@@ -6576,26 +6253,6 @@
                           <a:spcPts val="885"/>
                         </a:lnSpc>
                       </a:pPr>
-                      <a:r>
-                        <a:rPr sz="900" dirty="0">
-                          <a:solidFill>
-                            <a:srgbClr val="2B2B2B"/>
-                          </a:solidFill>
-                          <a:latin typeface="Arial"/>
-                          <a:cs typeface="Arial"/>
-                        </a:rPr>
-                        <a:t>. Telecharger ou imprimer un document depuis </a:t>
-                      </a:r>
-                      <a:r>
-                        <a:rPr sz="900" spc="-10" dirty="0">
-                          <a:solidFill>
-                            <a:srgbClr val="2B2B2B"/>
-                          </a:solidFill>
-                          <a:latin typeface="Arial"/>
-                          <a:cs typeface="Arial"/>
-                        </a:rPr>
-                        <a:t>Doctolib</a:t>
-                      </a:r>
                       <a:endParaRPr sz="900">
                         <a:latin typeface="Arial"/>
                         <a:cs typeface="Arial"/>

</xml_diff>

<commit_message>
fix: hauteur dynamique du bloc OPT selon le nombre de bullets
OPT_ROW_H fixe (1.65 cm) remplacé par opt_row_h() dynamique :
1.05 cm + 0.42 cm par bullet. Recalcul de total_h et décalages
des lignes dans draw_opt ; même correction dans le build_fiche.
Les 60 fiches PPTX (20 ateliers × 3 versions) sont regénérées.

Co-Authored-By: Claude Sonnet 4.6 <noreply@anthropic.com>
Claude-Session: https://claude.ai/code/session_01GGjUeQAdhFHN5BAn7y22FV
</commit_message>
<xml_diff>
--- a/assets/fiches/A6-fiche-1h.pptx
+++ b/assets/fiches/A6-fiche-1h.pptx
@@ -5491,7 +5491,7 @@
         <p:spPr>
           <a:xfrm>
             <a:off x="529200" y="540000"/>
-            <a:ext cx="6498000" cy="828000"/>
+            <a:ext cx="6498000" cy="1065600"/>
           </a:xfrm>
           <a:prstGeom prst="rect">
             <a:avLst/>
@@ -5658,7 +5658,7 @@
         <p:spPr>
           <a:xfrm>
             <a:off x="637200" y="781200"/>
-            <a:ext cx="6300000" cy="529200"/>
+            <a:ext cx="6300000" cy="766800"/>
           </a:xfrm>
           <a:prstGeom prst="rect">
             <a:avLst/>

</xml_diff>